<commit_message>
fix: deck — mentoring streams 13→12, soften unverifiable alumni "0 links"
Verified against the full scrape:
- Mentoring streams = 12, not 13. The alumni site has exactly 12 faculty-
  specific streams (/alumni/get-involved/volunteer/mentoring/faculty-specific/);
  the deck previously contradicted itself (slide 3 said 12, slide 5 said 13).
- The "0 links → alumni" claim rests on host-level outbound-link data only
  (no paths); alumni content lives on www.unimelb.edu.au/alumni, a host faculty
  pages link to 8,012 times, so "0 links to the alumni.unimelb.edu.au host"
  can't confirm faculty pages never link to /alumni. Reworded to "no direct
  links" on slide 5 (faculty→alumni and students→alumni), with the host-level
  caveat in the speaker notes; same fix in build.js / build-v2.js.

v3 regenerated via make_v3.py (correction applied to the copied Three-phases
slide); existing slides otherwise untouched. v2 .pptx left as-is.

Co-Authored-By: Claude Opus 4.8 <noreply@anthropic.com>
</commit_message>
<xml_diff>
--- a/discussion-deck/Current-Students-EndToEnd-Discussion-v3.pptx
+++ b/discussion-deck/Current-Students-EndToEnd-Discussion-v3.pptx
@@ -1068,8 +1068,7 @@
           <a:lstStyle/>
           <a:p>
             <a:r>
-              <a:rPr lang="en-US" dirty="0"/>
-              <a:t>Walk through the diagram (~5 min). The key insight is the faculty band spanning all three phases. Link flows (bottom section) show what the June 2026 crawl found: three active connections (faculty→students.unimelb 4,629 links; faculty→study 529 links; study→students.unimelb 273 links) and two completely broken connections (students.unimelb→alumni 0 links; faculty→alumni 0 links despite 13 mentoring streams existing on alumni.unimelb). The gap labels between core boxes show study→students.unimelb (273 links, active) and students→alumni (0 links, broken). Invite corrections to the picture — 'does this match what you see from your site's perspective?'</a:t>
+              <a:t>Walk through the diagram (~5 min). The key insight is the faculty band spanning all three phases. Link flows (bottom section) show what the June 2026 crawl found: three active connections (faculty→students.unimelb 4,629 links; faculty→study 529 links; study→students.unimelb 273 links) and two completely broken connections (students.unimelb→alumni 0 links; faculty→alumni 0 links despite 12 mentoring streams existing on alumni.unimelb). The gap labels between core boxes show study→students.unimelb (273 links, active) and students→alumni (0 links, broken). Invite corrections to the picture — 'does this match what you see from your site's perspective?'  CAVEAT on the alumni '0 links': the crawl recorded outbound links at HOST level only (no paths), and alumni content lives on www.unimelb.edu.au/alumni — a host faculty pages do link to. So 'no direct links' means zero links to the alumni.unimelb.edu.au host; confirming faculty pages never link to /alumni needs a path-level re-crawl. Mentoring streams = 12 (verified).</a:t>
             </a:r>
           </a:p>
         </p:txBody>
@@ -19516,7 +19515,7 @@
                 <a:ea typeface="Source Code Pro" pitchFamily="34" charset="-122"/>
                 <a:cs typeface="Source Code Pro" pitchFamily="34" charset="-120"/>
               </a:rPr>
-              <a:t>✗ 0</a:t>
+              <a:t>✗</a:t>
             </a:r>
             <a:endParaRPr lang="en-US" sz="700" dirty="0"/>
           </a:p>
@@ -19536,7 +19535,7 @@
                 <a:ea typeface="Source Code Pro" pitchFamily="34" charset="-122"/>
                 <a:cs typeface="Source Code Pro" pitchFamily="34" charset="-120"/>
               </a:rPr>
-              <a:t>links</a:t>
+              <a:t>none</a:t>
             </a:r>
             <a:endParaRPr lang="en-US" sz="700" dirty="0"/>
           </a:p>
@@ -19882,7 +19881,7 @@
                 <a:ea typeface="Source Sans 3" pitchFamily="34" charset="-122"/>
                 <a:cs typeface="Source Sans 3" pitchFamily="34" charset="-120"/>
               </a:rPr>
-              <a:t>13 faculty</a:t>
+              <a:t>12 faculty</a:t>
             </a:r>
             <a:endParaRPr lang="en-US" sz="900" dirty="0"/>
           </a:p>
@@ -19942,7 +19941,7 @@
                 <a:ea typeface="Source Sans 3" pitchFamily="34" charset="-122"/>
                 <a:cs typeface="Source Sans 3" pitchFamily="34" charset="-120"/>
               </a:rPr>
-              <a:t>✗ 0 links</a:t>
+              <a:t>✗ none found</a:t>
             </a:r>
             <a:endParaRPr lang="en-US" sz="900" dirty="0"/>
           </a:p>
@@ -20470,7 +20469,7 @@
                 <a:ea typeface="Source Code Pro" pitchFamily="34" charset="-122"/>
                 <a:cs typeface="Source Code Pro" pitchFamily="34" charset="-120"/>
               </a:rPr>
-              <a:t>0 links</a:t>
+              <a:t>no direct links</a:t>
             </a:r>
             <a:endParaRPr lang="en-US" sz="750" dirty="0"/>
           </a:p>
@@ -20580,7 +20579,7 @@
                 <a:ea typeface="Source Code Pro" pitchFamily="34" charset="-122"/>
                 <a:cs typeface="Source Code Pro" pitchFamily="34" charset="-120"/>
               </a:rPr>
-              <a:t>0 links — 13 mentoring streams not connected</a:t>
+              <a:t>no direct links · 12 mentoring streams</a:t>
             </a:r>
             <a:endParaRPr lang="en-US" sz="750" dirty="0"/>
           </a:p>

</xml_diff>